<commit_message>
Link final homework slide directly to expanded Week 4 guide
</commit_message>
<xml_diff>
--- a/lectures/w04-homework.pptx
+++ b/lectures/w04-homework.pptx
@@ -2,13 +2,13 @@
 <file path=ppt/presentation.xml><?xml version="1.0" encoding="utf-8"?>
 <p:presentation xmlns:p="http://schemas.openxmlformats.org/presentationml/2006/main">
   <p:sldMasterIdLst>
-    <p:sldMasterId xmlns:r="http://schemas.openxmlformats.org/officeDocument/2006/relationships" id="2147483648" r:id="R1a52d90b53204f2e"/>
+    <p:sldMasterId xmlns:r="http://schemas.openxmlformats.org/officeDocument/2006/relationships" id="2147483648" r:id="R301c32c7fee747f2"/>
   </p:sldMasterIdLst>
   <p:notesMasterIdLst>
-    <p:notesMasterId xmlns:r="http://schemas.openxmlformats.org/officeDocument/2006/relationships" r:id="R0b061bf504e24ec9"/>
+    <p:notesMasterId xmlns:r="http://schemas.openxmlformats.org/officeDocument/2006/relationships" r:id="R5503dec9532b4633"/>
   </p:notesMasterIdLst>
   <p:sldIdLst>
-    <p:sldId xmlns:r="http://schemas.openxmlformats.org/officeDocument/2006/relationships" id="256" r:id="R688e3c15fbbc4d93"/>
+    <p:sldId xmlns:r="http://schemas.openxmlformats.org/officeDocument/2006/relationships" id="256" r:id="R8ec2d373667e4506"/>
   </p:sldIdLst>
   <p:sldSz cx="12192000" cy="6858000"/>
   <p:notesSz cx="6858000" cy="9144000"/>
@@ -442,7 +442,7 @@
           <a:lstStyle xmlns:a="http://schemas.openxmlformats.org/drawingml/2006/main"/>
           <a:p xmlns:a="http://schemas.openxmlformats.org/drawingml/2006/main">
             <a:r>
-              <a:t>Week 4 simplified homework. Requirements from content/weeks/04-find-the-unexpected.md. At least two worksheets in one dashboard, at least one working filter, publish to Tableau Public. Submit the direct visualization link, one required screenshot with a second optional, a short explanation of the finding and filter, and data/source URL. Existing or new data allowed. Individual submission through the usual homework form. Resubmissions allowed until the deadline shown in the agenda. Guide: https://yohman.github.io/26-2-Dataviz/tableau-dashboard-guide.html</a:t>
+              <a:t>Week 4 simplified homework. Requirements from content/weeks/04-find-the-unexpected.md. At least two worksheets in one dashboard, at least one working filter, publish to Tableau Public. Submit the direct visualization link, one required screenshot with a second optional, a short explanation of the finding and filter, and data/source URL. Existing or new data allowed. Individual submission through the usual homework form. Resubmissions allowed until the deadline shown in the agenda. Guide: https://yohman.github.io/26-2-Dataviz/agenda.html#week-4-homework-guide</a:t>
             </a:r>
           </a:p>
         </p:txBody>
@@ -489,7 +489,7 @@
           <p:cNvPr id="3" name="Title">
             <a:extLst xmlns:a="http://schemas.openxmlformats.org/drawingml/2006/main">
               <a:ext uri="{FF2B5EF4-FFF2-40B4-BE49-F238E27FC236}">
-                <a16:creationId xmlns:a16="http://schemas.microsoft.com/office/drawing/2014/main" id="{C8269338-6C69-4323-9556-4E83B4D35EE4}"/>
+                <a16:creationId xmlns:a16="http://schemas.microsoft.com/office/drawing/2014/main" id="{E93ACFCE-5167-42BF-9710-F9D9CB124D65}"/>
               </a:ext>
             </a:extLst>
           </p:cNvPr>
@@ -646,7 +646,7 @@
           <p:cNvPr id="2" name="Subtitle">
             <a:extLst xmlns:a="http://schemas.openxmlformats.org/drawingml/2006/main">
               <a:ext uri="{FF2B5EF4-FFF2-40B4-BE49-F238E27FC236}">
-                <a16:creationId xmlns:a16="http://schemas.microsoft.com/office/drawing/2014/main" id="{64F5E10B-A229-4D07-9BCC-5430AE444A6D}"/>
+                <a16:creationId xmlns:a16="http://schemas.microsoft.com/office/drawing/2014/main" id="{CAFD4666-E770-4321-ADB1-DF567F501F0F}"/>
               </a:ext>
             </a:extLst>
           </p:cNvPr>
@@ -820,7 +820,7 @@
           <p:cNvPr id="2" name="Section title">
             <a:extLst xmlns:a="http://schemas.openxmlformats.org/drawingml/2006/main">
               <a:ext uri="{FF2B5EF4-FFF2-40B4-BE49-F238E27FC236}">
-                <a16:creationId xmlns:a16="http://schemas.microsoft.com/office/drawing/2014/main" id="{E23C8D13-9F7F-4F4B-A776-DE03AB8CA25F}"/>
+                <a16:creationId xmlns:a16="http://schemas.microsoft.com/office/drawing/2014/main" id="{C32C9E82-0D09-4189-9DA9-EA7C4EA5672B}"/>
               </a:ext>
             </a:extLst>
           </p:cNvPr>
@@ -994,7 +994,7 @@
           <p:cNvPr id="3" name="Title">
             <a:extLst xmlns:a="http://schemas.openxmlformats.org/drawingml/2006/main">
               <a:ext uri="{FF2B5EF4-FFF2-40B4-BE49-F238E27FC236}">
-                <a16:creationId xmlns:a16="http://schemas.microsoft.com/office/drawing/2014/main" id="{AF349599-2810-4037-9FB6-46C1BEADDF65}"/>
+                <a16:creationId xmlns:a16="http://schemas.microsoft.com/office/drawing/2014/main" id="{FA9EC37D-17B9-449E-886D-451899CB8055}"/>
               </a:ext>
             </a:extLst>
           </p:cNvPr>
@@ -1151,7 +1151,7 @@
           <p:cNvPr id="2" name="Body">
             <a:extLst xmlns:a="http://schemas.openxmlformats.org/drawingml/2006/main">
               <a:ext uri="{FF2B5EF4-FFF2-40B4-BE49-F238E27FC236}">
-                <a16:creationId xmlns:a16="http://schemas.microsoft.com/office/drawing/2014/main" id="{18E419EC-DF18-4F9A-8C29-5530E364A610}"/>
+                <a16:creationId xmlns:a16="http://schemas.microsoft.com/office/drawing/2014/main" id="{30F2F0A7-FC7B-4E6B-B032-60D0632DB612}"/>
               </a:ext>
             </a:extLst>
           </p:cNvPr>
@@ -1325,7 +1325,7 @@
           <p:cNvPr id="4" name="Title">
             <a:extLst xmlns:a="http://schemas.openxmlformats.org/drawingml/2006/main">
               <a:ext uri="{FF2B5EF4-FFF2-40B4-BE49-F238E27FC236}">
-                <a16:creationId xmlns:a16="http://schemas.microsoft.com/office/drawing/2014/main" id="{84671F3A-30C9-4248-A49F-E1BE5EAEB662}"/>
+                <a16:creationId xmlns:a16="http://schemas.microsoft.com/office/drawing/2014/main" id="{6EA595EF-6678-4D7C-AC66-19BB93E07ECE}"/>
               </a:ext>
             </a:extLst>
           </p:cNvPr>
@@ -1482,7 +1482,7 @@
           <p:cNvPr id="2" name="Left column">
             <a:extLst xmlns:a="http://schemas.openxmlformats.org/drawingml/2006/main">
               <a:ext uri="{FF2B5EF4-FFF2-40B4-BE49-F238E27FC236}">
-                <a16:creationId xmlns:a16="http://schemas.microsoft.com/office/drawing/2014/main" id="{9D8BFD40-7FD9-4106-9CB1-631606D401F4}"/>
+                <a16:creationId xmlns:a16="http://schemas.microsoft.com/office/drawing/2014/main" id="{95B7B7BC-F988-4840-A39F-AB78FAE406EF}"/>
               </a:ext>
             </a:extLst>
           </p:cNvPr>
@@ -1639,7 +1639,7 @@
           <p:cNvPr id="3" name="Right column">
             <a:extLst xmlns:a="http://schemas.openxmlformats.org/drawingml/2006/main">
               <a:ext uri="{FF2B5EF4-FFF2-40B4-BE49-F238E27FC236}">
-                <a16:creationId xmlns:a16="http://schemas.microsoft.com/office/drawing/2014/main" id="{C38D3B7B-48FA-486E-8CD0-D770A79EB470}"/>
+                <a16:creationId xmlns:a16="http://schemas.microsoft.com/office/drawing/2014/main" id="{85C0F7B3-32CD-45FA-9BED-E1F861908767}"/>
               </a:ext>
             </a:extLst>
           </p:cNvPr>
@@ -1813,7 +1813,7 @@
           <p:cNvPr id="3" name="Title">
             <a:extLst xmlns:a="http://schemas.openxmlformats.org/drawingml/2006/main">
               <a:ext uri="{FF2B5EF4-FFF2-40B4-BE49-F238E27FC236}">
-                <a16:creationId xmlns:a16="http://schemas.microsoft.com/office/drawing/2014/main" id="{A1BB03FA-69E2-4AA9-BFE2-82FC3F489855}"/>
+                <a16:creationId xmlns:a16="http://schemas.microsoft.com/office/drawing/2014/main" id="{E38666C2-B225-4003-94D3-610B5E4F2B77}"/>
               </a:ext>
             </a:extLst>
           </p:cNvPr>
@@ -1970,7 +1970,7 @@
           <p:cNvPr id="2" name="Left column">
             <a:extLst xmlns:a="http://schemas.openxmlformats.org/drawingml/2006/main">
               <a:ext uri="{FF2B5EF4-FFF2-40B4-BE49-F238E27FC236}">
-                <a16:creationId xmlns:a16="http://schemas.microsoft.com/office/drawing/2014/main" id="{FD246460-53CA-4B51-B0CD-D3486E12BEEF}"/>
+                <a16:creationId xmlns:a16="http://schemas.microsoft.com/office/drawing/2014/main" id="{6A714580-C01F-4B67-B624-67AF92F12305}"/>
               </a:ext>
             </a:extLst>
           </p:cNvPr>
@@ -2165,12 +2165,12 @@
   </p:cSld>
   <p:clrMap bg1="lt1" tx1="dk1" bg2="lt2" tx2="dk2" accent1="accent1" accent2="accent2" accent3="accent3" accent4="accent4" accent5="accent5" accent6="accent6" hlink="hlink" folHlink="folHlink"/>
   <p:sldLayoutIdLst>
-    <p:sldLayoutId xmlns:r="http://schemas.openxmlformats.org/officeDocument/2006/relationships" id="2147483649" r:id="Rbaf90ba77c564778"/>
-    <p:sldLayoutId xmlns:r="http://schemas.openxmlformats.org/officeDocument/2006/relationships" id="2147483650" r:id="R5f0a54db0b66473c"/>
-    <p:sldLayoutId xmlns:r="http://schemas.openxmlformats.org/officeDocument/2006/relationships" id="2147483651" r:id="Rafd9c0ccf53c4667"/>
-    <p:sldLayoutId xmlns:r="http://schemas.openxmlformats.org/officeDocument/2006/relationships" id="2147483652" r:id="R5d5b14f6975a4c6a"/>
-    <p:sldLayoutId xmlns:r="http://schemas.openxmlformats.org/officeDocument/2006/relationships" id="2147483653" r:id="R1eb57d890fef415e"/>
-    <p:sldLayoutId xmlns:r="http://schemas.openxmlformats.org/officeDocument/2006/relationships" id="2147483654" r:id="Ra0bb561e3cfc42a2"/>
+    <p:sldLayoutId xmlns:r="http://schemas.openxmlformats.org/officeDocument/2006/relationships" id="2147483649" r:id="R0694ae92e13c49d3"/>
+    <p:sldLayoutId xmlns:r="http://schemas.openxmlformats.org/officeDocument/2006/relationships" id="2147483650" r:id="R83cc2ae40a7343b6"/>
+    <p:sldLayoutId xmlns:r="http://schemas.openxmlformats.org/officeDocument/2006/relationships" id="2147483651" r:id="R114e01da633f49ff"/>
+    <p:sldLayoutId xmlns:r="http://schemas.openxmlformats.org/officeDocument/2006/relationships" id="2147483652" r:id="R2d5446d4bb404c89"/>
+    <p:sldLayoutId xmlns:r="http://schemas.openxmlformats.org/officeDocument/2006/relationships" id="2147483653" r:id="R2e3fab717eeb452d"/>
+    <p:sldLayoutId xmlns:r="http://schemas.openxmlformats.org/officeDocument/2006/relationships" id="2147483654" r:id="Rfadf2ef6fc0d4b76"/>
   </p:sldLayoutIdLst>
   <p:txStyles>
     <p:titleStyle>
@@ -2721,7 +2721,7 @@
           <p:cNvPr id="13" name="">
             <a:extLst xmlns:a="http://schemas.openxmlformats.org/drawingml/2006/main">
               <a:ext uri="{FF2B5EF4-FFF2-40B4-BE49-F238E27FC236}">
-                <a16:creationId xmlns:a16="http://schemas.microsoft.com/office/drawing/2014/main" id="{1A7F2F26-D94E-41A4-B915-AD465A4EE778}"/>
+                <a16:creationId xmlns:a16="http://schemas.microsoft.com/office/drawing/2014/main" id="{066B930A-BBC4-486D-A71C-EFEE9CEDA908}"/>
               </a:ext>
             </a:extLst>
           </p:cNvPr>
@@ -2787,7 +2787,7 @@
           <p:cNvPr id="2" name="">
             <a:extLst xmlns:a="http://schemas.openxmlformats.org/drawingml/2006/main">
               <a:ext uri="{FF2B5EF4-FFF2-40B4-BE49-F238E27FC236}">
-                <a16:creationId xmlns:a16="http://schemas.microsoft.com/office/drawing/2014/main" id="{DF1CBBD5-94A2-4D2D-A619-6F700F25A120}"/>
+                <a16:creationId xmlns:a16="http://schemas.microsoft.com/office/drawing/2014/main" id="{2042958D-989E-4E5B-91C2-9ADD6046E0E0}"/>
               </a:ext>
             </a:extLst>
           </p:cNvPr>
@@ -2853,7 +2853,7 @@
           <p:cNvPr id="3" name="">
             <a:extLst xmlns:a="http://schemas.openxmlformats.org/drawingml/2006/main">
               <a:ext uri="{FF2B5EF4-FFF2-40B4-BE49-F238E27FC236}">
-                <a16:creationId xmlns:a16="http://schemas.microsoft.com/office/drawing/2014/main" id="{4B440751-199D-4278-8115-CCA14C6A057D}"/>
+                <a16:creationId xmlns:a16="http://schemas.microsoft.com/office/drawing/2014/main" id="{410274CB-CC54-437C-83B3-29F60962D2D5}"/>
               </a:ext>
             </a:extLst>
           </p:cNvPr>
@@ -2919,7 +2919,7 @@
           <p:cNvPr id="4" name="">
             <a:extLst xmlns:a="http://schemas.openxmlformats.org/drawingml/2006/main">
               <a:ext uri="{FF2B5EF4-FFF2-40B4-BE49-F238E27FC236}">
-                <a16:creationId xmlns:a16="http://schemas.microsoft.com/office/drawing/2014/main" id="{5782761F-A46F-46FF-AE97-F38BDE5E865C}"/>
+                <a16:creationId xmlns:a16="http://schemas.microsoft.com/office/drawing/2014/main" id="{8BCCBDF7-E17A-41EE-B13B-3BE301500E41}"/>
               </a:ext>
             </a:extLst>
           </p:cNvPr>
@@ -2985,7 +2985,7 @@
           <p:cNvPr id="5" name="">
             <a:extLst xmlns:a="http://schemas.openxmlformats.org/drawingml/2006/main">
               <a:ext uri="{FF2B5EF4-FFF2-40B4-BE49-F238E27FC236}">
-                <a16:creationId xmlns:a16="http://schemas.microsoft.com/office/drawing/2014/main" id="{B17E9EDC-FC66-4D7D-9EF2-E349E0F60086}"/>
+                <a16:creationId xmlns:a16="http://schemas.microsoft.com/office/drawing/2014/main" id="{7FB0756C-70B2-4F8B-A17C-E721C0B83EE0}"/>
               </a:ext>
             </a:extLst>
           </p:cNvPr>
@@ -3051,7 +3051,7 @@
           <p:cNvPr id="6" name="">
             <a:extLst xmlns:a="http://schemas.openxmlformats.org/drawingml/2006/main">
               <a:ext uri="{FF2B5EF4-FFF2-40B4-BE49-F238E27FC236}">
-                <a16:creationId xmlns:a16="http://schemas.microsoft.com/office/drawing/2014/main" id="{0E1296B0-25F9-46A7-AC81-543C2C2161E3}"/>
+                <a16:creationId xmlns:a16="http://schemas.microsoft.com/office/drawing/2014/main" id="{3C8AB7EE-D5A1-40AD-9731-3BE6F56F2229}"/>
               </a:ext>
             </a:extLst>
           </p:cNvPr>
@@ -3117,7 +3117,7 @@
           <p:cNvPr id="7" name="">
             <a:extLst xmlns:a="http://schemas.openxmlformats.org/drawingml/2006/main">
               <a:ext uri="{FF2B5EF4-FFF2-40B4-BE49-F238E27FC236}">
-                <a16:creationId xmlns:a16="http://schemas.microsoft.com/office/drawing/2014/main" id="{BC848900-40A6-45E7-862E-EC15A3C26B68}"/>
+                <a16:creationId xmlns:a16="http://schemas.microsoft.com/office/drawing/2014/main" id="{AA229220-FE4A-414A-82F5-997E78F734C1}"/>
               </a:ext>
             </a:extLst>
           </p:cNvPr>
@@ -3183,7 +3183,7 @@
           <p:cNvPr id="8" name="">
             <a:extLst xmlns:a="http://schemas.openxmlformats.org/drawingml/2006/main">
               <a:ext uri="{FF2B5EF4-FFF2-40B4-BE49-F238E27FC236}">
-                <a16:creationId xmlns:a16="http://schemas.microsoft.com/office/drawing/2014/main" id="{B437DF01-318A-45D7-A5AB-DFDA8A83DF96}"/>
+                <a16:creationId xmlns:a16="http://schemas.microsoft.com/office/drawing/2014/main" id="{198F46E4-2A39-4311-B62C-CD9FA6FCB2F0}"/>
               </a:ext>
             </a:extLst>
           </p:cNvPr>
@@ -3249,7 +3249,7 @@
           <p:cNvPr id="9" name="">
             <a:extLst xmlns:a="http://schemas.openxmlformats.org/drawingml/2006/main">
               <a:ext uri="{FF2B5EF4-FFF2-40B4-BE49-F238E27FC236}">
-                <a16:creationId xmlns:a16="http://schemas.microsoft.com/office/drawing/2014/main" id="{8E2E1793-86AB-4CE7-80FE-9E8EAAEA89F5}"/>
+                <a16:creationId xmlns:a16="http://schemas.microsoft.com/office/drawing/2014/main" id="{216FC281-A44E-4A0D-8D54-1A7AB90DF334}"/>
               </a:ext>
             </a:extLst>
           </p:cNvPr>
@@ -3315,7 +3315,7 @@
           <p:cNvPr id="10" name="">
             <a:extLst xmlns:a="http://schemas.openxmlformats.org/drawingml/2006/main">
               <a:ext uri="{FF2B5EF4-FFF2-40B4-BE49-F238E27FC236}">
-                <a16:creationId xmlns:a16="http://schemas.microsoft.com/office/drawing/2014/main" id="{3490E014-8A6B-4DDB-8258-BDB3D041872D}"/>
+                <a16:creationId xmlns:a16="http://schemas.microsoft.com/office/drawing/2014/main" id="{4990E05A-B835-4CA9-9CC1-2E4E8F8953DA}"/>
               </a:ext>
             </a:extLst>
           </p:cNvPr>
@@ -3404,7 +3404,7 @@
           <p:cNvPr id="11" name="">
             <a:extLst xmlns:a="http://schemas.openxmlformats.org/drawingml/2006/main">
               <a:ext uri="{FF2B5EF4-FFF2-40B4-BE49-F238E27FC236}">
-                <a16:creationId xmlns:a16="http://schemas.microsoft.com/office/drawing/2014/main" id="{A5DABAA0-06B7-4A01-A8F9-70A746645140}"/>
+                <a16:creationId xmlns:a16="http://schemas.microsoft.com/office/drawing/2014/main" id="{6572910A-4818-4C09-B1A3-A0A348A462CE}"/>
               </a:ext>
             </a:extLst>
           </p:cNvPr>
@@ -3453,7 +3453,7 @@
             </a:pPr>
             <a:r>
               <a:rPr u="sng">
-                <a:hlinkClick xmlns:r="http://schemas.openxmlformats.org/officeDocument/2006/relationships" r:id="Rb390caa95e314c1e"/>
+                <a:hlinkClick xmlns:r="http://schemas.openxmlformats.org/officeDocument/2006/relationships" r:id="Rb8016bc4898b483a"/>
               </a:rPr>
               <a:t>How-to guide</a:t>
             </a:r>
@@ -3465,7 +3465,7 @@
           <p:cNvPr id="12" name="">
             <a:extLst xmlns:a="http://schemas.openxmlformats.org/drawingml/2006/main">
               <a:ext uri="{FF2B5EF4-FFF2-40B4-BE49-F238E27FC236}">
-                <a16:creationId xmlns:a16="http://schemas.microsoft.com/office/drawing/2014/main" id="{DD6932C6-B725-4085-9464-E6E3A50251CF}"/>
+                <a16:creationId xmlns:a16="http://schemas.microsoft.com/office/drawing/2014/main" id="{252DAC29-25CB-4B26-878C-143EF52AC800}"/>
               </a:ext>
             </a:extLst>
           </p:cNvPr>
@@ -3529,7 +3529,7 @@
     </p:spTree>
     <p:extLst>
       <p:ext uri="{BB962C8B-B14F-4D97-AF65-F5344CB8AC3E}">
-        <p14:creationId xmlns:p14="http://schemas.microsoft.com/office/powerpoint/2010/main" val="706789932"/>
+        <p14:creationId xmlns:p14="http://schemas.microsoft.com/office/powerpoint/2010/main" val="1866483949"/>
       </p:ext>
     </p:extLst>
   </p:cSld>

</xml_diff>